<commit_message>
Add Resources slide with PDFs, Slack, and office hours
Append a single Resources slide listing the SRM Field Playbook and CM
Training Deck PDFs plus #temp-stacking-questions-26, NA/WGS office hours,
webinar, and Growth@ notice. Include both source PDFs in the folder.

Co-authored-by: bhannigan-cpu <bhannigan-cpu@users.noreply.github.com>
</commit_message>
<xml_diff>
--- a/discount-stacking-enablement/B2B_Discount_Stacking_Team_Enablement.pptx
+++ b/discount-stacking-enablement/B2B_Discount_Stacking_Team_Enablement.pptx
@@ -10,6 +10,7 @@
     <p:sldId id="258" r:id="rId9"/>
     <p:sldId id="259" r:id="rId10"/>
     <p:sldId id="260" r:id="rId11"/>
+    <p:sldId id="261" r:id="rId12"/>
   </p:sldIdLst>
   <p:sldSz cx="12191695" cy="6858000" type="screen4x3"/>
   <p:notesSz cx="6858000" cy="9144000"/>
@@ -3329,7 +3330,7 @@
                 </a:solidFill>
                 <a:latin typeface="Calibri"/>
               </a:rPr>
-              <a:t>What you'll walk away with: timeline · ask ladder · who to call first · conversation guardrails</a:t>
+              <a:t>What you'll walk away with: timeline · ask ladder · who to call first · conversation guardrails · resources</a:t>
             </a:r>
           </a:p>
         </p:txBody>
@@ -3407,7 +3408,7 @@
                 </a:solidFill>
                 <a:latin typeface="Calibri"/>
               </a:rPr>
-              <a:t>1/5</a:t>
+              <a:t>1/6</a:t>
             </a:r>
           </a:p>
         </p:txBody>
@@ -4653,7 +4654,7 @@
                 </a:solidFill>
                 <a:latin typeface="Calibri"/>
               </a:rPr>
-              <a:t>Support: #temp-stacking-questions-26  ·  Office hours: NA Tue/Thu 3:30 PM ET · WGS Wed 4:00 PM ET</a:t>
+              <a:t>Support details on Resources slide →</a:t>
             </a:r>
           </a:p>
         </p:txBody>
@@ -4731,7 +4732,7 @@
                 </a:solidFill>
                 <a:latin typeface="Calibri"/>
               </a:rPr>
-              <a:t>2/5</a:t>
+              <a:t>2/6</a:t>
             </a:r>
           </a:p>
         </p:txBody>
@@ -5729,7 +5730,7 @@
                 </a:solidFill>
                 <a:latin typeface="Calibri"/>
               </a:rPr>
-              <a:t>3/5</a:t>
+              <a:t>3/6</a:t>
             </a:r>
           </a:p>
         </p:txBody>
@@ -7035,7 +7036,7 @@
                 </a:solidFill>
                 <a:latin typeface="Calibri"/>
               </a:rPr>
-              <a:t>4/5</a:t>
+              <a:t>4/6</a:t>
             </a:r>
           </a:p>
         </p:txBody>
@@ -7916,7 +7917,1184 @@
                 </a:solidFill>
                 <a:latin typeface="Calibri"/>
               </a:rPr>
-              <a:t>5/5</a:t>
+              <a:t>5/6</a:t>
+            </a:r>
+          </a:p>
+        </p:txBody>
+      </p:sp>
+    </p:spTree>
+  </p:cSld>
+  <p:clrMapOvr>
+    <a:masterClrMapping/>
+  </p:clrMapOvr>
+</p:sld>
+</file>
+
+<file path=ppt/slides/slide6.xml><?xml version="1.0" encoding="utf-8"?>
+<p:sld xmlns:a="http://schemas.openxmlformats.org/drawingml/2006/main" xmlns:p="http://schemas.openxmlformats.org/presentationml/2006/main" xmlns:r="http://schemas.openxmlformats.org/officeDocument/2006/relationships">
+  <p:cSld>
+    <p:spTree>
+      <p:nvGrpSpPr>
+        <p:cNvPr id="1" name=""/>
+        <p:cNvGrpSpPr/>
+        <p:nvPr/>
+      </p:nvGrpSpPr>
+      <p:grpSpPr/>
+      <p:sp>
+        <p:nvSpPr>
+          <p:cNvPr id="2" name="Rectangle 1"/>
+          <p:cNvSpPr/>
+          <p:nvPr/>
+        </p:nvSpPr>
+        <p:spPr>
+          <a:xfrm>
+            <a:off x="0" y="0"/>
+            <a:ext cx="12191695" cy="6858000"/>
+          </a:xfrm>
+          <a:prstGeom prst="rect">
+            <a:avLst/>
+          </a:prstGeom>
+          <a:solidFill>
+            <a:srgbClr val="F7F9FA"/>
+          </a:solidFill>
+          <a:ln>
+            <a:noFill/>
+          </a:ln>
+        </p:spPr>
+        <p:style>
+          <a:lnRef idx="1">
+            <a:schemeClr val="accent1"/>
+          </a:lnRef>
+          <a:fillRef idx="3">
+            <a:schemeClr val="accent1"/>
+          </a:fillRef>
+          <a:effectRef idx="2">
+            <a:schemeClr val="accent1"/>
+          </a:effectRef>
+          <a:fontRef idx="minor">
+            <a:schemeClr val="lt1"/>
+          </a:fontRef>
+        </p:style>
+        <p:txBody>
+          <a:bodyPr rtlCol="0" anchor="ctr"/>
+          <a:lstStyle/>
+          <a:p>
+            <a:pPr algn="ctr"/>
+          </a:p>
+        </p:txBody>
+      </p:sp>
+      <p:sp>
+        <p:nvSpPr>
+          <p:cNvPr id="3" name="Rectangle 2"/>
+          <p:cNvSpPr/>
+          <p:nvPr/>
+        </p:nvSpPr>
+        <p:spPr>
+          <a:xfrm>
+            <a:off x="0" y="0"/>
+            <a:ext cx="12191695" cy="109728"/>
+          </a:xfrm>
+          <a:prstGeom prst="rect">
+            <a:avLst/>
+          </a:prstGeom>
+          <a:solidFill>
+            <a:srgbClr val="0F6B6B"/>
+          </a:solidFill>
+          <a:ln>
+            <a:noFill/>
+          </a:ln>
+        </p:spPr>
+        <p:style>
+          <a:lnRef idx="1">
+            <a:schemeClr val="accent1"/>
+          </a:lnRef>
+          <a:fillRef idx="3">
+            <a:schemeClr val="accent1"/>
+          </a:fillRef>
+          <a:effectRef idx="2">
+            <a:schemeClr val="accent1"/>
+          </a:effectRef>
+          <a:fontRef idx="minor">
+            <a:schemeClr val="lt1"/>
+          </a:fontRef>
+        </p:style>
+        <p:txBody>
+          <a:bodyPr rtlCol="0" anchor="ctr"/>
+          <a:lstStyle/>
+          <a:p>
+            <a:pPr algn="ctr"/>
+          </a:p>
+        </p:txBody>
+      </p:sp>
+      <p:sp>
+        <p:nvSpPr>
+          <p:cNvPr id="4" name="TextBox 3"/>
+          <p:cNvSpPr txBox="1"/>
+          <p:nvPr/>
+        </p:nvSpPr>
+        <p:spPr>
+          <a:xfrm>
+            <a:off x="548640" y="320040"/>
+            <a:ext cx="10972800" cy="502920"/>
+          </a:xfrm>
+          <a:prstGeom prst="rect">
+            <a:avLst/>
+          </a:prstGeom>
+          <a:noFill/>
+        </p:spPr>
+        <p:txBody>
+          <a:bodyPr wrap="square">
+            <a:spAutoFit/>
+          </a:bodyPr>
+          <a:lstStyle/>
+          <a:p>
+            <a:pPr algn="l">
+              <a:spcAft>
+                <a:spcPts val="400"/>
+              </a:spcAft>
+            </a:pPr>
+            <a:r>
+              <a:rPr sz="3200" b="1">
+                <a:solidFill>
+                  <a:srgbClr val="0B1F33"/>
+                </a:solidFill>
+                <a:latin typeface="Calibri"/>
+              </a:rPr>
+              <a:t>Resources</a:t>
+            </a:r>
+          </a:p>
+        </p:txBody>
+      </p:sp>
+      <p:sp>
+        <p:nvSpPr>
+          <p:cNvPr id="5" name="TextBox 4"/>
+          <p:cNvSpPr txBox="1"/>
+          <p:nvPr/>
+        </p:nvSpPr>
+        <p:spPr>
+          <a:xfrm>
+            <a:off x="548640" y="868680"/>
+            <a:ext cx="10972800" cy="320040"/>
+          </a:xfrm>
+          <a:prstGeom prst="rect">
+            <a:avLst/>
+          </a:prstGeom>
+          <a:noFill/>
+        </p:spPr>
+        <p:txBody>
+          <a:bodyPr wrap="square">
+            <a:spAutoFit/>
+          </a:bodyPr>
+          <a:lstStyle/>
+          <a:p>
+            <a:pPr algn="l">
+              <a:spcAft>
+                <a:spcPts val="400"/>
+              </a:spcAft>
+            </a:pPr>
+            <a:r>
+              <a:rPr sz="1500" b="0">
+                <a:solidFill>
+                  <a:srgbClr val="5B6B78"/>
+                </a:solidFill>
+                <a:latin typeface="Calibri"/>
+              </a:rPr>
+              <a:t>Everything your team needs in one place — docs, Slack, and office hours.</a:t>
+            </a:r>
+          </a:p>
+        </p:txBody>
+      </p:sp>
+      <p:sp>
+        <p:nvSpPr>
+          <p:cNvPr id="6" name="Rectangle 5"/>
+          <p:cNvSpPr/>
+          <p:nvPr/>
+        </p:nvSpPr>
+        <p:spPr>
+          <a:xfrm>
+            <a:off x="548640" y="1325880"/>
+            <a:ext cx="5486400" cy="4754880"/>
+          </a:xfrm>
+          <a:prstGeom prst="rect">
+            <a:avLst/>
+          </a:prstGeom>
+          <a:solidFill>
+            <a:srgbClr val="FFFFFF"/>
+          </a:solidFill>
+          <a:ln w="12700">
+            <a:solidFill>
+              <a:srgbClr val="D5DEE5"/>
+            </a:solidFill>
+          </a:ln>
+        </p:spPr>
+        <p:style>
+          <a:lnRef idx="1">
+            <a:schemeClr val="accent1"/>
+          </a:lnRef>
+          <a:fillRef idx="3">
+            <a:schemeClr val="accent1"/>
+          </a:fillRef>
+          <a:effectRef idx="2">
+            <a:schemeClr val="accent1"/>
+          </a:effectRef>
+          <a:fontRef idx="minor">
+            <a:schemeClr val="lt1"/>
+          </a:fontRef>
+        </p:style>
+        <p:txBody>
+          <a:bodyPr rtlCol="0" anchor="ctr"/>
+          <a:lstStyle/>
+          <a:p>
+            <a:pPr algn="ctr"/>
+          </a:p>
+        </p:txBody>
+      </p:sp>
+      <p:sp>
+        <p:nvSpPr>
+          <p:cNvPr id="7" name="TextBox 6"/>
+          <p:cNvSpPr txBox="1"/>
+          <p:nvPr/>
+        </p:nvSpPr>
+        <p:spPr>
+          <a:xfrm>
+            <a:off x="777240" y="1508760"/>
+            <a:ext cx="5029200" cy="365760"/>
+          </a:xfrm>
+          <a:prstGeom prst="rect">
+            <a:avLst/>
+          </a:prstGeom>
+          <a:noFill/>
+        </p:spPr>
+        <p:txBody>
+          <a:bodyPr wrap="square">
+            <a:spAutoFit/>
+          </a:bodyPr>
+          <a:lstStyle/>
+          <a:p>
+            <a:pPr algn="l">
+              <a:spcAft>
+                <a:spcPts val="400"/>
+              </a:spcAft>
+            </a:pPr>
+            <a:r>
+              <a:rPr sz="1300" b="1">
+                <a:solidFill>
+                  <a:srgbClr val="0F6B6B"/>
+                </a:solidFill>
+                <a:latin typeface="Calibri"/>
+              </a:rPr>
+              <a:t>CORE DOCUMENTS</a:t>
+            </a:r>
+          </a:p>
+        </p:txBody>
+      </p:sp>
+      <p:sp>
+        <p:nvSpPr>
+          <p:cNvPr id="8" name="Rectangle 7"/>
+          <p:cNvSpPr/>
+          <p:nvPr/>
+        </p:nvSpPr>
+        <p:spPr>
+          <a:xfrm>
+            <a:off x="777240" y="2011680"/>
+            <a:ext cx="5029200" cy="1234440"/>
+          </a:xfrm>
+          <a:prstGeom prst="rect">
+            <a:avLst/>
+          </a:prstGeom>
+          <a:solidFill>
+            <a:srgbClr val="E6F3F3"/>
+          </a:solidFill>
+          <a:ln>
+            <a:noFill/>
+          </a:ln>
+        </p:spPr>
+        <p:style>
+          <a:lnRef idx="1">
+            <a:schemeClr val="accent1"/>
+          </a:lnRef>
+          <a:fillRef idx="3">
+            <a:schemeClr val="accent1"/>
+          </a:fillRef>
+          <a:effectRef idx="2">
+            <a:schemeClr val="accent1"/>
+          </a:effectRef>
+          <a:fontRef idx="minor">
+            <a:schemeClr val="lt1"/>
+          </a:fontRef>
+        </p:style>
+        <p:txBody>
+          <a:bodyPr rtlCol="0" anchor="ctr"/>
+          <a:lstStyle/>
+          <a:p>
+            <a:pPr algn="ctr"/>
+          </a:p>
+        </p:txBody>
+      </p:sp>
+      <p:sp>
+        <p:nvSpPr>
+          <p:cNvPr id="9" name="TextBox 8"/>
+          <p:cNvSpPr txBox="1"/>
+          <p:nvPr/>
+        </p:nvSpPr>
+        <p:spPr>
+          <a:xfrm>
+            <a:off x="960120" y="2194560"/>
+            <a:ext cx="4663440" cy="411480"/>
+          </a:xfrm>
+          <a:prstGeom prst="rect">
+            <a:avLst/>
+          </a:prstGeom>
+          <a:noFill/>
+        </p:spPr>
+        <p:txBody>
+          <a:bodyPr wrap="square">
+            <a:spAutoFit/>
+          </a:bodyPr>
+          <a:lstStyle/>
+          <a:p>
+            <a:pPr algn="l">
+              <a:spcAft>
+                <a:spcPts val="400"/>
+              </a:spcAft>
+            </a:pPr>
+            <a:r>
+              <a:rPr sz="1500" b="1">
+                <a:solidFill>
+                  <a:srgbClr val="0B1F33"/>
+                </a:solidFill>
+                <a:latin typeface="Calibri"/>
+              </a:rPr>
+              <a:t>Discount Stacking — SRM Field Playbook</a:t>
+            </a:r>
+          </a:p>
+        </p:txBody>
+      </p:sp>
+      <p:sp>
+        <p:nvSpPr>
+          <p:cNvPr id="10" name="TextBox 9"/>
+          <p:cNvSpPr txBox="1"/>
+          <p:nvPr/>
+        </p:nvSpPr>
+        <p:spPr>
+          <a:xfrm>
+            <a:off x="960120" y="2651760"/>
+            <a:ext cx="4663440" cy="457200"/>
+          </a:xfrm>
+          <a:prstGeom prst="rect">
+            <a:avLst/>
+          </a:prstGeom>
+          <a:noFill/>
+        </p:spPr>
+        <p:txBody>
+          <a:bodyPr wrap="square">
+            <a:spAutoFit/>
+          </a:bodyPr>
+          <a:lstStyle/>
+          <a:p>
+            <a:pPr algn="l">
+              <a:spcAft>
+                <a:spcPts val="400"/>
+              </a:spcAft>
+            </a:pPr>
+            <a:r>
+              <a:rPr sz="1300" b="0">
+                <a:solidFill>
+                  <a:srgbClr val="2C3A47"/>
+                </a:solidFill>
+                <a:latin typeface="Calibri"/>
+              </a:rPr>
+              <a:t>PDF in this folder · Timeline, ask ladder, talk tracks, FAQs, escalation</a:t>
+            </a:r>
+          </a:p>
+        </p:txBody>
+      </p:sp>
+      <p:sp>
+        <p:nvSpPr>
+          <p:cNvPr id="11" name="Rectangle 10"/>
+          <p:cNvSpPr/>
+          <p:nvPr/>
+        </p:nvSpPr>
+        <p:spPr>
+          <a:xfrm>
+            <a:off x="777240" y="3429000"/>
+            <a:ext cx="5029200" cy="1234440"/>
+          </a:xfrm>
+          <a:prstGeom prst="rect">
+            <a:avLst/>
+          </a:prstGeom>
+          <a:solidFill>
+            <a:srgbClr val="E6F3F3"/>
+          </a:solidFill>
+          <a:ln>
+            <a:noFill/>
+          </a:ln>
+        </p:spPr>
+        <p:style>
+          <a:lnRef idx="1">
+            <a:schemeClr val="accent1"/>
+          </a:lnRef>
+          <a:fillRef idx="3">
+            <a:schemeClr val="accent1"/>
+          </a:fillRef>
+          <a:effectRef idx="2">
+            <a:schemeClr val="accent1"/>
+          </a:effectRef>
+          <a:fontRef idx="minor">
+            <a:schemeClr val="lt1"/>
+          </a:fontRef>
+        </p:style>
+        <p:txBody>
+          <a:bodyPr rtlCol="0" anchor="ctr"/>
+          <a:lstStyle/>
+          <a:p>
+            <a:pPr algn="ctr"/>
+          </a:p>
+        </p:txBody>
+      </p:sp>
+      <p:sp>
+        <p:nvSpPr>
+          <p:cNvPr id="12" name="TextBox 11"/>
+          <p:cNvSpPr txBox="1"/>
+          <p:nvPr/>
+        </p:nvSpPr>
+        <p:spPr>
+          <a:xfrm>
+            <a:off x="960120" y="3611880"/>
+            <a:ext cx="4663440" cy="411480"/>
+          </a:xfrm>
+          <a:prstGeom prst="rect">
+            <a:avLst/>
+          </a:prstGeom>
+          <a:noFill/>
+        </p:spPr>
+        <p:txBody>
+          <a:bodyPr wrap="square">
+            <a:spAutoFit/>
+          </a:bodyPr>
+          <a:lstStyle/>
+          <a:p>
+            <a:pPr algn="l">
+              <a:spcAft>
+                <a:spcPts val="400"/>
+              </a:spcAft>
+            </a:pPr>
+            <a:r>
+              <a:rPr sz="1500" b="1">
+                <a:solidFill>
+                  <a:srgbClr val="0B1F33"/>
+                </a:solidFill>
+                <a:latin typeface="Calibri"/>
+              </a:rPr>
+              <a:t>Discount Stacking CM Training Deck</a:t>
+            </a:r>
+          </a:p>
+        </p:txBody>
+      </p:sp>
+      <p:sp>
+        <p:nvSpPr>
+          <p:cNvPr id="13" name="TextBox 12"/>
+          <p:cNvSpPr txBox="1"/>
+          <p:nvPr/>
+        </p:nvSpPr>
+        <p:spPr>
+          <a:xfrm>
+            <a:off x="960120" y="4069080"/>
+            <a:ext cx="4663440" cy="457200"/>
+          </a:xfrm>
+          <a:prstGeom prst="rect">
+            <a:avLst/>
+          </a:prstGeom>
+          <a:noFill/>
+        </p:spPr>
+        <p:txBody>
+          <a:bodyPr wrap="square">
+            <a:spAutoFit/>
+          </a:bodyPr>
+          <a:lstStyle/>
+          <a:p>
+            <a:pPr algn="l">
+              <a:spcAft>
+                <a:spcPts val="400"/>
+              </a:spcAft>
+            </a:pPr>
+            <a:r>
+              <a:rPr sz="1300" b="0">
+                <a:solidFill>
+                  <a:srgbClr val="2C3A47"/>
+                </a:solidFill>
+                <a:latin typeface="Calibri"/>
+              </a:rPr>
+              <a:t>PDF in this folder · Full mechanics, examples, B2B &amp; item-level deal detail</a:t>
+            </a:r>
+          </a:p>
+        </p:txBody>
+      </p:sp>
+      <p:sp>
+        <p:nvSpPr>
+          <p:cNvPr id="14" name="TextBox 13"/>
+          <p:cNvSpPr txBox="1"/>
+          <p:nvPr/>
+        </p:nvSpPr>
+        <p:spPr>
+          <a:xfrm>
+            <a:off x="777240" y="5029200"/>
+            <a:ext cx="5029200" cy="731520"/>
+          </a:xfrm>
+          <a:prstGeom prst="rect">
+            <a:avLst/>
+          </a:prstGeom>
+          <a:noFill/>
+        </p:spPr>
+        <p:txBody>
+          <a:bodyPr wrap="square">
+            <a:spAutoFit/>
+          </a:bodyPr>
+          <a:lstStyle/>
+          <a:p>
+            <a:pPr algn="l">
+              <a:spcAft>
+                <a:spcPts val="400"/>
+              </a:spcAft>
+            </a:pPr>
+            <a:r>
+              <a:rPr sz="1200" b="0">
+                <a:solidFill>
+                  <a:srgbClr val="5B6B78"/>
+                </a:solidFill>
+                <a:latin typeface="Calibri"/>
+              </a:rPr>
+              <a:t>Also useful: supplier-level impact data · talk tracks doc · B2B CM InfoHub / Negotiation Hub</a:t>
+            </a:r>
+          </a:p>
+        </p:txBody>
+      </p:sp>
+      <p:sp>
+        <p:nvSpPr>
+          <p:cNvPr id="15" name="Rectangle 14"/>
+          <p:cNvSpPr/>
+          <p:nvPr/>
+        </p:nvSpPr>
+        <p:spPr>
+          <a:xfrm>
+            <a:off x="6263640" y="1325880"/>
+            <a:ext cx="5349240" cy="4754880"/>
+          </a:xfrm>
+          <a:prstGeom prst="rect">
+            <a:avLst/>
+          </a:prstGeom>
+          <a:solidFill>
+            <a:srgbClr val="FFFFFF"/>
+          </a:solidFill>
+          <a:ln w="12700">
+            <a:solidFill>
+              <a:srgbClr val="D5DEE5"/>
+            </a:solidFill>
+          </a:ln>
+        </p:spPr>
+        <p:style>
+          <a:lnRef idx="1">
+            <a:schemeClr val="accent1"/>
+          </a:lnRef>
+          <a:fillRef idx="3">
+            <a:schemeClr val="accent1"/>
+          </a:fillRef>
+          <a:effectRef idx="2">
+            <a:schemeClr val="accent1"/>
+          </a:effectRef>
+          <a:fontRef idx="minor">
+            <a:schemeClr val="lt1"/>
+          </a:fontRef>
+        </p:style>
+        <p:txBody>
+          <a:bodyPr rtlCol="0" anchor="ctr"/>
+          <a:lstStyle/>
+          <a:p>
+            <a:pPr algn="ctr"/>
+          </a:p>
+        </p:txBody>
+      </p:sp>
+      <p:sp>
+        <p:nvSpPr>
+          <p:cNvPr id="16" name="TextBox 15"/>
+          <p:cNvSpPr txBox="1"/>
+          <p:nvPr/>
+        </p:nvSpPr>
+        <p:spPr>
+          <a:xfrm>
+            <a:off x="6492240" y="1508760"/>
+            <a:ext cx="4937760" cy="365760"/>
+          </a:xfrm>
+          <a:prstGeom prst="rect">
+            <a:avLst/>
+          </a:prstGeom>
+          <a:noFill/>
+        </p:spPr>
+        <p:txBody>
+          <a:bodyPr wrap="square">
+            <a:spAutoFit/>
+          </a:bodyPr>
+          <a:lstStyle/>
+          <a:p>
+            <a:pPr algn="l">
+              <a:spcAft>
+                <a:spcPts val="400"/>
+              </a:spcAft>
+            </a:pPr>
+            <a:r>
+              <a:rPr sz="1300" b="1">
+                <a:solidFill>
+                  <a:srgbClr val="0F6B6B"/>
+                </a:solidFill>
+                <a:latin typeface="Calibri"/>
+              </a:rPr>
+              <a:t>WHERE TO GET HELP</a:t>
+            </a:r>
+          </a:p>
+        </p:txBody>
+      </p:sp>
+      <p:sp>
+        <p:nvSpPr>
+          <p:cNvPr id="17" name="TextBox 16"/>
+          <p:cNvSpPr txBox="1"/>
+          <p:nvPr/>
+        </p:nvSpPr>
+        <p:spPr>
+          <a:xfrm>
+            <a:off x="6492240" y="2011680"/>
+            <a:ext cx="4937760" cy="274320"/>
+          </a:xfrm>
+          <a:prstGeom prst="rect">
+            <a:avLst/>
+          </a:prstGeom>
+          <a:noFill/>
+        </p:spPr>
+        <p:txBody>
+          <a:bodyPr wrap="square">
+            <a:spAutoFit/>
+          </a:bodyPr>
+          <a:lstStyle/>
+          <a:p>
+            <a:pPr algn="l">
+              <a:spcAft>
+                <a:spcPts val="400"/>
+              </a:spcAft>
+            </a:pPr>
+            <a:r>
+              <a:rPr sz="1200" b="1">
+                <a:solidFill>
+                  <a:srgbClr val="5B6B78"/>
+                </a:solidFill>
+                <a:latin typeface="Calibri"/>
+              </a:rPr>
+              <a:t>Slack</a:t>
+            </a:r>
+          </a:p>
+        </p:txBody>
+      </p:sp>
+      <p:sp>
+        <p:nvSpPr>
+          <p:cNvPr id="18" name="TextBox 17"/>
+          <p:cNvSpPr txBox="1"/>
+          <p:nvPr/>
+        </p:nvSpPr>
+        <p:spPr>
+          <a:xfrm>
+            <a:off x="6492240" y="2240280"/>
+            <a:ext cx="4937760" cy="320040"/>
+          </a:xfrm>
+          <a:prstGeom prst="rect">
+            <a:avLst/>
+          </a:prstGeom>
+          <a:noFill/>
+        </p:spPr>
+        <p:txBody>
+          <a:bodyPr wrap="square">
+            <a:spAutoFit/>
+          </a:bodyPr>
+          <a:lstStyle/>
+          <a:p>
+            <a:pPr algn="l">
+              <a:spcAft>
+                <a:spcPts val="400"/>
+              </a:spcAft>
+            </a:pPr>
+            <a:r>
+              <a:rPr sz="1500" b="1">
+                <a:solidFill>
+                  <a:srgbClr val="0B1F33"/>
+                </a:solidFill>
+                <a:latin typeface="Calibri"/>
+              </a:rPr>
+              <a:t>#temp-stacking-questions-26</a:t>
+            </a:r>
+          </a:p>
+        </p:txBody>
+      </p:sp>
+      <p:sp>
+        <p:nvSpPr>
+          <p:cNvPr id="19" name="TextBox 18"/>
+          <p:cNvSpPr txBox="1"/>
+          <p:nvPr/>
+        </p:nvSpPr>
+        <p:spPr>
+          <a:xfrm>
+            <a:off x="6492240" y="2606040"/>
+            <a:ext cx="4937760" cy="274320"/>
+          </a:xfrm>
+          <a:prstGeom prst="rect">
+            <a:avLst/>
+          </a:prstGeom>
+          <a:noFill/>
+        </p:spPr>
+        <p:txBody>
+          <a:bodyPr wrap="square">
+            <a:spAutoFit/>
+          </a:bodyPr>
+          <a:lstStyle/>
+          <a:p>
+            <a:pPr algn="l">
+              <a:spcAft>
+                <a:spcPts val="400"/>
+              </a:spcAft>
+            </a:pPr>
+            <a:r>
+              <a:rPr sz="1200" b="1">
+                <a:solidFill>
+                  <a:srgbClr val="5B6B78"/>
+                </a:solidFill>
+                <a:latin typeface="Calibri"/>
+              </a:rPr>
+              <a:t>Office hours — NA</a:t>
+            </a:r>
+          </a:p>
+        </p:txBody>
+      </p:sp>
+      <p:sp>
+        <p:nvSpPr>
+          <p:cNvPr id="20" name="TextBox 19"/>
+          <p:cNvSpPr txBox="1"/>
+          <p:nvPr/>
+        </p:nvSpPr>
+        <p:spPr>
+          <a:xfrm>
+            <a:off x="6492240" y="2834640"/>
+            <a:ext cx="4937760" cy="320040"/>
+          </a:xfrm>
+          <a:prstGeom prst="rect">
+            <a:avLst/>
+          </a:prstGeom>
+          <a:noFill/>
+        </p:spPr>
+        <p:txBody>
+          <a:bodyPr wrap="square">
+            <a:spAutoFit/>
+          </a:bodyPr>
+          <a:lstStyle/>
+          <a:p>
+            <a:pPr algn="l">
+              <a:spcAft>
+                <a:spcPts val="400"/>
+              </a:spcAft>
+            </a:pPr>
+            <a:r>
+              <a:rPr sz="1500" b="1">
+                <a:solidFill>
+                  <a:srgbClr val="0B1F33"/>
+                </a:solidFill>
+                <a:latin typeface="Calibri"/>
+              </a:rPr>
+              <a:t>Tue &amp; Thu · 3:30 PM ET</a:t>
+            </a:r>
+          </a:p>
+        </p:txBody>
+      </p:sp>
+      <p:sp>
+        <p:nvSpPr>
+          <p:cNvPr id="21" name="TextBox 20"/>
+          <p:cNvSpPr txBox="1"/>
+          <p:nvPr/>
+        </p:nvSpPr>
+        <p:spPr>
+          <a:xfrm>
+            <a:off x="6492240" y="3200400"/>
+            <a:ext cx="4937760" cy="274320"/>
+          </a:xfrm>
+          <a:prstGeom prst="rect">
+            <a:avLst/>
+          </a:prstGeom>
+          <a:noFill/>
+        </p:spPr>
+        <p:txBody>
+          <a:bodyPr wrap="square">
+            <a:spAutoFit/>
+          </a:bodyPr>
+          <a:lstStyle/>
+          <a:p>
+            <a:pPr algn="l">
+              <a:spcAft>
+                <a:spcPts val="400"/>
+              </a:spcAft>
+            </a:pPr>
+            <a:r>
+              <a:rPr sz="1200" b="1">
+                <a:solidFill>
+                  <a:srgbClr val="5B6B78"/>
+                </a:solidFill>
+                <a:latin typeface="Calibri"/>
+              </a:rPr>
+              <a:t>Office hours — WGS</a:t>
+            </a:r>
+          </a:p>
+        </p:txBody>
+      </p:sp>
+      <p:sp>
+        <p:nvSpPr>
+          <p:cNvPr id="22" name="TextBox 21"/>
+          <p:cNvSpPr txBox="1"/>
+          <p:nvPr/>
+        </p:nvSpPr>
+        <p:spPr>
+          <a:xfrm>
+            <a:off x="6492240" y="3429000"/>
+            <a:ext cx="4937760" cy="320040"/>
+          </a:xfrm>
+          <a:prstGeom prst="rect">
+            <a:avLst/>
+          </a:prstGeom>
+          <a:noFill/>
+        </p:spPr>
+        <p:txBody>
+          <a:bodyPr wrap="square">
+            <a:spAutoFit/>
+          </a:bodyPr>
+          <a:lstStyle/>
+          <a:p>
+            <a:pPr algn="l">
+              <a:spcAft>
+                <a:spcPts val="400"/>
+              </a:spcAft>
+            </a:pPr>
+            <a:r>
+              <a:rPr sz="1500" b="1">
+                <a:solidFill>
+                  <a:srgbClr val="0B1F33"/>
+                </a:solidFill>
+                <a:latin typeface="Calibri"/>
+              </a:rPr>
+              <a:t>Wed · 4:00–4:30 PM ET</a:t>
+            </a:r>
+          </a:p>
+        </p:txBody>
+      </p:sp>
+      <p:sp>
+        <p:nvSpPr>
+          <p:cNvPr id="23" name="TextBox 22"/>
+          <p:cNvSpPr txBox="1"/>
+          <p:nvPr/>
+        </p:nvSpPr>
+        <p:spPr>
+          <a:xfrm>
+            <a:off x="6492240" y="3794760"/>
+            <a:ext cx="4937760" cy="274320"/>
+          </a:xfrm>
+          <a:prstGeom prst="rect">
+            <a:avLst/>
+          </a:prstGeom>
+          <a:noFill/>
+        </p:spPr>
+        <p:txBody>
+          <a:bodyPr wrap="square">
+            <a:spAutoFit/>
+          </a:bodyPr>
+          <a:lstStyle/>
+          <a:p>
+            <a:pPr algn="l">
+              <a:spcAft>
+                <a:spcPts val="400"/>
+              </a:spcAft>
+            </a:pPr>
+            <a:r>
+              <a:rPr sz="1200" b="1">
+                <a:solidFill>
+                  <a:srgbClr val="5B6B78"/>
+                </a:solidFill>
+                <a:latin typeface="Calibri"/>
+              </a:rPr>
+              <a:t>Supplier webinar</a:t>
+            </a:r>
+          </a:p>
+        </p:txBody>
+      </p:sp>
+      <p:sp>
+        <p:nvSpPr>
+          <p:cNvPr id="24" name="TextBox 23"/>
+          <p:cNvSpPr txBox="1"/>
+          <p:nvPr/>
+        </p:nvSpPr>
+        <p:spPr>
+          <a:xfrm>
+            <a:off x="6492240" y="4023360"/>
+            <a:ext cx="4937760" cy="320040"/>
+          </a:xfrm>
+          <a:prstGeom prst="rect">
+            <a:avLst/>
+          </a:prstGeom>
+          <a:noFill/>
+        </p:spPr>
+        <p:txBody>
+          <a:bodyPr wrap="square">
+            <a:spAutoFit/>
+          </a:bodyPr>
+          <a:lstStyle/>
+          <a:p>
+            <a:pPr algn="l">
+              <a:spcAft>
+                <a:spcPts val="400"/>
+              </a:spcAft>
+            </a:pPr>
+            <a:r>
+              <a:rPr sz="1500" b="1">
+                <a:solidFill>
+                  <a:srgbClr val="0B1F33"/>
+                </a:solidFill>
+                <a:latin typeface="Calibri"/>
+              </a:rPr>
+              <a:t>Tue, Oct 13 · 11:00 AM ET</a:t>
+            </a:r>
+          </a:p>
+        </p:txBody>
+      </p:sp>
+      <p:sp>
+        <p:nvSpPr>
+          <p:cNvPr id="25" name="TextBox 24"/>
+          <p:cNvSpPr txBox="1"/>
+          <p:nvPr/>
+        </p:nvSpPr>
+        <p:spPr>
+          <a:xfrm>
+            <a:off x="6492240" y="4389120"/>
+            <a:ext cx="4937760" cy="274320"/>
+          </a:xfrm>
+          <a:prstGeom prst="rect">
+            <a:avLst/>
+          </a:prstGeom>
+          <a:noFill/>
+        </p:spPr>
+        <p:txBody>
+          <a:bodyPr wrap="square">
+            <a:spAutoFit/>
+          </a:bodyPr>
+          <a:lstStyle/>
+          <a:p>
+            <a:pPr algn="l">
+              <a:spcAft>
+                <a:spcPts val="400"/>
+              </a:spcAft>
+            </a:pPr>
+            <a:r>
+              <a:rPr sz="1200" b="1">
+                <a:solidFill>
+                  <a:srgbClr val="5B6B78"/>
+                </a:solidFill>
+                <a:latin typeface="Calibri"/>
+              </a:rPr>
+              <a:t>Supplier notice</a:t>
+            </a:r>
+          </a:p>
+        </p:txBody>
+      </p:sp>
+      <p:sp>
+        <p:nvSpPr>
+          <p:cNvPr id="26" name="TextBox 25"/>
+          <p:cNvSpPr txBox="1"/>
+          <p:nvPr/>
+        </p:nvSpPr>
+        <p:spPr>
+          <a:xfrm>
+            <a:off x="6492240" y="4617720"/>
+            <a:ext cx="4937760" cy="320040"/>
+          </a:xfrm>
+          <a:prstGeom prst="rect">
+            <a:avLst/>
+          </a:prstGeom>
+          <a:noFill/>
+        </p:spPr>
+        <p:txBody>
+          <a:bodyPr wrap="square">
+            <a:spAutoFit/>
+          </a:bodyPr>
+          <a:lstStyle/>
+          <a:p>
+            <a:pPr algn="l">
+              <a:spcAft>
+                <a:spcPts val="400"/>
+              </a:spcAft>
+            </a:pPr>
+            <a:r>
+              <a:rPr sz="1500" b="1">
+                <a:solidFill>
+                  <a:srgbClr val="0B1F33"/>
+                </a:solidFill>
+                <a:latin typeface="Calibri"/>
+              </a:rPr>
+              <a:t>Growth@ · deployed Sep 28 (follow up within 48h)</a:t>
+            </a:r>
+          </a:p>
+        </p:txBody>
+      </p:sp>
+      <p:sp>
+        <p:nvSpPr>
+          <p:cNvPr id="27" name="TextBox 26"/>
+          <p:cNvSpPr txBox="1"/>
+          <p:nvPr/>
+        </p:nvSpPr>
+        <p:spPr>
+          <a:xfrm>
+            <a:off x="6492240" y="4983480"/>
+            <a:ext cx="4937760" cy="274320"/>
+          </a:xfrm>
+          <a:prstGeom prst="rect">
+            <a:avLst/>
+          </a:prstGeom>
+          <a:noFill/>
+        </p:spPr>
+        <p:txBody>
+          <a:bodyPr wrap="square">
+            <a:spAutoFit/>
+          </a:bodyPr>
+          <a:lstStyle/>
+          <a:p>
+            <a:pPr algn="l">
+              <a:spcAft>
+                <a:spcPts val="400"/>
+              </a:spcAft>
+            </a:pPr>
+            <a:r>
+              <a:rPr sz="1200" b="1">
+                <a:solidFill>
+                  <a:srgbClr val="5B6B78"/>
+                </a:solidFill>
+                <a:latin typeface="Calibri"/>
+              </a:rPr>
+              <a:t>Go-live</a:t>
+            </a:r>
+          </a:p>
+        </p:txBody>
+      </p:sp>
+      <p:sp>
+        <p:nvSpPr>
+          <p:cNvPr id="28" name="TextBox 27"/>
+          <p:cNvSpPr txBox="1"/>
+          <p:nvPr/>
+        </p:nvSpPr>
+        <p:spPr>
+          <a:xfrm>
+            <a:off x="6492240" y="5212080"/>
+            <a:ext cx="4937760" cy="320040"/>
+          </a:xfrm>
+          <a:prstGeom prst="rect">
+            <a:avLst/>
+          </a:prstGeom>
+          <a:noFill/>
+        </p:spPr>
+        <p:txBody>
+          <a:bodyPr wrap="square">
+            <a:spAutoFit/>
+          </a:bodyPr>
+          <a:lstStyle/>
+          <a:p>
+            <a:pPr algn="l">
+              <a:spcAft>
+                <a:spcPts val="400"/>
+              </a:spcAft>
+            </a:pPr>
+            <a:r>
+              <a:rPr sz="1500" b="1">
+                <a:solidFill>
+                  <a:srgbClr val="0B1F33"/>
+                </a:solidFill>
+                <a:latin typeface="Calibri"/>
+              </a:rPr>
+              <a:t>Mon, Nov 9 — spot-check hero SKUs</a:t>
+            </a:r>
+          </a:p>
+        </p:txBody>
+      </p:sp>
+      <p:sp>
+        <p:nvSpPr>
+          <p:cNvPr id="29" name="TextBox 28"/>
+          <p:cNvSpPr txBox="1"/>
+          <p:nvPr/>
+        </p:nvSpPr>
+        <p:spPr>
+          <a:xfrm>
+            <a:off x="548640" y="6446520"/>
+            <a:ext cx="9144000" cy="274320"/>
+          </a:xfrm>
+          <a:prstGeom prst="rect">
+            <a:avLst/>
+          </a:prstGeom>
+          <a:noFill/>
+        </p:spPr>
+        <p:txBody>
+          <a:bodyPr wrap="square">
+            <a:spAutoFit/>
+          </a:bodyPr>
+          <a:lstStyle/>
+          <a:p>
+            <a:pPr algn="l">
+              <a:spcAft>
+                <a:spcPts val="400"/>
+              </a:spcAft>
+            </a:pPr>
+            <a:r>
+              <a:rPr sz="1100" b="0">
+                <a:solidFill>
+                  <a:srgbClr val="5B6B78"/>
+                </a:solidFill>
+                <a:latin typeface="Calibri"/>
+              </a:rPr>
+              <a:t>B2B Discount Stacking · Internal enablement · Confidential</a:t>
+            </a:r>
+          </a:p>
+        </p:txBody>
+      </p:sp>
+      <p:sp>
+        <p:nvSpPr>
+          <p:cNvPr id="30" name="TextBox 29"/>
+          <p:cNvSpPr txBox="1"/>
+          <p:nvPr/>
+        </p:nvSpPr>
+        <p:spPr>
+          <a:xfrm>
+            <a:off x="10789920" y="6446520"/>
+            <a:ext cx="914400" cy="274320"/>
+          </a:xfrm>
+          <a:prstGeom prst="rect">
+            <a:avLst/>
+          </a:prstGeom>
+          <a:noFill/>
+        </p:spPr>
+        <p:txBody>
+          <a:bodyPr wrap="square">
+            <a:spAutoFit/>
+          </a:bodyPr>
+          <a:lstStyle/>
+          <a:p>
+            <a:pPr algn="r">
+              <a:spcAft>
+                <a:spcPts val="400"/>
+              </a:spcAft>
+            </a:pPr>
+            <a:r>
+              <a:rPr sz="1100" b="0">
+                <a:solidFill>
+                  <a:srgbClr val="5B6B78"/>
+                </a:solidFill>
+                <a:latin typeface="Calibri"/>
+              </a:rPr>
+              <a:t>6/6</a:t>
             </a:r>
           </a:p>
         </p:txBody>

</xml_diff>